<commit_message>
feat: ship v3.2.1 with toss payments review requirements
Co-Authored-By: Claude Opus 5 (1M context) <noreply@anthropic.com>
Claude-Session: https://claude.ai/code/session_01CVrbYxTbJ955i6xJC2FERz
</commit_message>
<xml_diff>
--- a/docs/toss/AI4CEO_결제경로_ai4ceog1fz.pptx
+++ b/docs/toss/AI4CEO_결제경로_ai4ceog1fz.pptx
@@ -12,6 +12,7 @@
     <p:sldId id="260" r:id="rId6"/>
     <p:sldId id="261" r:id="rId7"/>
     <p:sldId id="262" r:id="rId8"/>
+    <p:sldId id="264" r:id="rId15"/>
     <p:sldId id="263" r:id="rId9"/>
   </p:sldIdLst>
   <p:notesMasterIdLst>
@@ -1602,6 +1603,10 @@
             <a:prstDash val="solid"/>
           </a:ln>
         </p:spPr>
+        <p:txBody>
+          <a:bodyPr/>
+          <a:p/>
+        </p:txBody>
       </p:sp>
       <p:sp>
         <p:nvSpPr>
@@ -1758,7 +1763,7 @@
                 <a:ea typeface="맑은 고딕" pitchFamily="34" charset="-122"/>
                 <a:cs typeface="맑은 고딕" pitchFamily="34" charset="-120"/>
               </a:rPr>
-              <a:t>2026. 08. 11.</a:t>
+              <a:t>2026. 09. 07.</a:t>
             </a:r>
             <a:endParaRPr lang="en-US" sz="1300" dirty="0"/>
           </a:p>
@@ -2301,7 +2306,7 @@
                 <a:ea typeface="맑은 고딕" pitchFamily="34" charset="-122"/>
                 <a:cs typeface="맑은 고딕" pitchFamily="34" charset="-120"/>
               </a:rPr>
-              <a:t>신용·체크카드 / 간편결제</a:t>
+              <a:t>신용·체크카드 / 계좌이체 / 가상계좌</a:t>
             </a:r>
             <a:endParaRPr lang="en-US" sz="1300" dirty="0"/>
           </a:p>
@@ -2597,8 +2602,8 @@
         </p:blipFill>
         <p:spPr>
           <a:xfrm>
-            <a:off x="822960" y="5257800"/>
-            <a:ext cx="10515600" cy="1188720"/>
+            <a:off x="2968475" y="5257800"/>
+            <a:ext cx="6224570" cy="1188720"/>
           </a:xfrm>
           <a:prstGeom prst="rect">
             <a:avLst/>
@@ -2935,8 +2940,8 @@
         </p:blipFill>
         <p:spPr>
           <a:xfrm>
-            <a:off x="4983480" y="868680"/>
-            <a:ext cx="6309360" cy="5029200"/>
+            <a:off x="4983480" y="1192530"/>
+            <a:ext cx="6309360" cy="4381500"/>
           </a:xfrm>
           <a:prstGeom prst="rect">
             <a:avLst/>
@@ -3297,8 +3302,8 @@
         </p:blipFill>
         <p:spPr>
           <a:xfrm>
-            <a:off x="4983480" y="868680"/>
-            <a:ext cx="6309360" cy="5029200"/>
+            <a:off x="4983480" y="1547431"/>
+            <a:ext cx="6309360" cy="3671697"/>
           </a:xfrm>
           <a:prstGeom prst="rect">
             <a:avLst/>
@@ -4287,7 +4292,7 @@
                 <a:ea typeface="맑은 고딕" pitchFamily="34" charset="-122"/>
                 <a:cs typeface="맑은 고딕" pitchFamily="34" charset="-120"/>
               </a:rPr>
-              <a:t>상품마다 [결제하기] 버튼이 있어 원하는 상품을 바로 결제할 수 있습니다.</a:t>
+              <a:t>상품마다 [결제하기] 버튼이 있고, 상품 카드에 서비스 제공기간을 함께 표기합니다.</a:t>
             </a:r>
             <a:endParaRPr lang="en-US" sz="1300" dirty="0"/>
           </a:p>
@@ -4311,7 +4316,31 @@
                 <a:ea typeface="맑은 고딕" pitchFamily="34" charset="-122"/>
                 <a:cs typeface="맑은 고딕" pitchFamily="34" charset="-120"/>
               </a:rPr>
-              <a:t>하단에 결제수단·환불 규정을 함께 안내합니다. 두 경로 모두 로그인 없이 결제할 수 있고, 동일한 토스페이먼츠 표준 결제창을 사용합니다.</a:t>
+              <a:t>하단에 결제수단·환불 규정을 안내하며, 자세한 내용은 [결제 및 환불 정책](/terms)으로 연결됩니다.</a:t>
+            </a:r>
+            <a:endParaRPr lang="en-US" sz="1300" dirty="0"/>
+          </a:p>
+          <a:p>
+            <a:pPr marL="342900" indent="-342900">
+              <a:lnSpc>
+                <a:spcPct val="125000"/>
+              </a:lnSpc>
+              <a:spcAft>
+                <a:spcPts val="800"/>
+              </a:spcAft>
+              <a:buSzPct val="100000"/>
+              <a:buChar char="•"/>
+            </a:pPr>
+            <a:r>
+              <a:rPr lang="en-US" sz="1300" dirty="0">
+                <a:solidFill>
+                  <a:srgbClr val="5B6472"/>
+                </a:solidFill>
+                <a:latin typeface="맑은 고딕" pitchFamily="34" charset="0"/>
+                <a:ea typeface="맑은 고딕" pitchFamily="34" charset="-122"/>
+                <a:cs typeface="맑은 고딕" pitchFamily="34" charset="-120"/>
+              </a:rPr>
+              <a:t>두 경로 모두 로그인 없이 결제할 수 있고, 동일한 토스페이먼츠 표준 결제창을 사용합니다.</a:t>
             </a:r>
             <a:endParaRPr lang="en-US" sz="1300" dirty="0"/>
           </a:p>
@@ -4359,8 +4388,8 @@
         </p:blipFill>
         <p:spPr>
           <a:xfrm>
-            <a:off x="4983480" y="868680"/>
-            <a:ext cx="6309360" cy="5029200"/>
+            <a:off x="5542444" y="868680"/>
+            <a:ext cx="5191432" cy="5029200"/>
           </a:xfrm>
           <a:prstGeom prst="rect">
             <a:avLst/>
@@ -4376,6 +4405,379 @@
 </file>
 
 <file path=ppt/slides/slide8.xml><?xml version="1.0" encoding="utf-8"?>
+<p:sld xmlns:a="http://schemas.openxmlformats.org/drawingml/2006/main" xmlns:p="http://schemas.openxmlformats.org/presentationml/2006/main" xmlns:r="http://schemas.openxmlformats.org/officeDocument/2006/relationships">
+  <p:cSld>
+    <p:spTree>
+      <p:nvGrpSpPr>
+        <p:cNvPr id="1" name=""/>
+        <p:cNvGrpSpPr/>
+        <p:nvPr/>
+      </p:nvGrpSpPr>
+      <p:grpSpPr/>
+      <p:sp>
+        <p:nvSpPr>
+          <p:cNvPr id="2" name="Shape 0"/>
+          <p:cNvSpPr/>
+          <p:nvPr/>
+        </p:nvSpPr>
+        <p:spPr>
+          <a:xfrm>
+            <a:off x="822960" y="548640"/>
+            <a:ext cx="1234440" cy="384048"/>
+          </a:xfrm>
+          <a:prstGeom prst="roundRect">
+            <a:avLst>
+              <a:gd name="adj" fmla="val 23810"/>
+            </a:avLst>
+          </a:prstGeom>
+          <a:solidFill>
+            <a:srgbClr val="1E2761"/>
+          </a:solidFill>
+          <a:ln w="12700">
+            <a:solidFill>
+              <a:srgbClr val="1E2761"/>
+            </a:solidFill>
+            <a:prstDash val="solid"/>
+          </a:ln>
+        </p:spPr>
+      </p:sp>
+      <p:sp>
+        <p:nvSpPr>
+          <p:cNvPr id="3" name="Text 1"/>
+          <p:cNvSpPr/>
+          <p:nvPr/>
+        </p:nvSpPr>
+        <p:spPr>
+          <a:xfrm>
+            <a:off x="822960" y="548640"/>
+            <a:ext cx="1234440" cy="384048"/>
+          </a:xfrm>
+          <a:prstGeom prst="rect">
+            <a:avLst/>
+          </a:prstGeom>
+          <a:noFill/>
+          <a:ln/>
+        </p:spPr>
+        <p:txBody>
+          <a:bodyPr wrap="square" lIns="0" tIns="0" rIns="0" bIns="0" rtlCol="0" anchor="t"/>
+          <a:lstStyle/>
+          <a:p>
+            <a:pPr algn="ctr" indent="0" marL="0">
+              <a:buNone/>
+            </a:pPr>
+            <a:r>
+              <a:rPr lang="en-US" sz="1200" b="1" dirty="0">
+                <a:solidFill>
+                  <a:srgbClr val="FFFFFF"/>
+                </a:solidFill>
+                <a:latin typeface="맑은 고딕" pitchFamily="34" charset="0"/>
+                <a:ea typeface="맑은 고딕" pitchFamily="34" charset="-122"/>
+                <a:cs typeface="맑은 고딕" pitchFamily="34" charset="-120"/>
+              </a:rPr>
+              <a:t>참고</a:t>
+            </a:r>
+            <a:endParaRPr lang="en-US" sz="1200" dirty="0"/>
+          </a:p>
+        </p:txBody>
+      </p:sp>
+      <p:sp>
+        <p:nvSpPr>
+          <p:cNvPr id="4" name="Text 2"/>
+          <p:cNvSpPr/>
+          <p:nvPr/>
+        </p:nvSpPr>
+        <p:spPr>
+          <a:xfrm>
+            <a:off x="822960" y="1097280"/>
+            <a:ext cx="3886200" cy="1005840"/>
+          </a:xfrm>
+          <a:prstGeom prst="rect">
+            <a:avLst/>
+          </a:prstGeom>
+          <a:noFill/>
+          <a:ln/>
+        </p:spPr>
+        <p:txBody>
+          <a:bodyPr wrap="square" lIns="0" tIns="0" rIns="0" bIns="0" rtlCol="0" anchor="t"/>
+          <a:lstStyle/>
+          <a:p>
+            <a:pPr indent="0" marL="0">
+              <a:lnSpc>
+                <a:spcPct val="120000"/>
+              </a:lnSpc>
+              <a:buNone/>
+            </a:pPr>
+            <a:r>
+              <a:rPr lang="en-US" sz="2200" b="1" dirty="0">
+                <a:solidFill>
+                  <a:srgbClr val="1E2761"/>
+                </a:solidFill>
+                <a:latin typeface="맑은 고딕" pitchFamily="34" charset="0"/>
+                <a:ea typeface="맑은 고딕" pitchFamily="34" charset="-122"/>
+                <a:cs typeface="맑은 고딕" pitchFamily="34" charset="-120"/>
+              </a:rPr>
+              <a:t>결제 및 환불 정책</a:t>
+            </a:r>
+            <a:endParaRPr lang="en-US" sz="2200" dirty="0"/>
+          </a:p>
+        </p:txBody>
+      </p:sp>
+      <p:sp>
+        <p:nvSpPr>
+          <p:cNvPr id="5" name="Text 3"/>
+          <p:cNvSpPr/>
+          <p:nvPr/>
+        </p:nvSpPr>
+        <p:spPr>
+          <a:xfrm>
+            <a:off x="822960" y="2240280"/>
+            <a:ext cx="3657600" cy="228600"/>
+          </a:xfrm>
+          <a:prstGeom prst="rect">
+            <a:avLst/>
+          </a:prstGeom>
+          <a:noFill/>
+          <a:ln/>
+        </p:spPr>
+        <p:txBody>
+          <a:bodyPr wrap="square" lIns="0" tIns="0" rIns="0" bIns="0" rtlCol="0" anchor="t"/>
+          <a:lstStyle/>
+          <a:p>
+            <a:pPr indent="0" marL="0">
+              <a:buNone/>
+            </a:pPr>
+            <a:r>
+              <a:rPr lang="en-US" sz="1000" b="1" dirty="0">
+                <a:solidFill>
+                  <a:srgbClr val="2C5CE6"/>
+                </a:solidFill>
+                <a:latin typeface="맑은 고딕" pitchFamily="34" charset="0"/>
+                <a:ea typeface="맑은 고딕" pitchFamily="34" charset="-122"/>
+                <a:cs typeface="맑은 고딕" pitchFamily="34" charset="-120"/>
+              </a:rPr>
+              <a:t>URL</a:t>
+            </a:r>
+            <a:endParaRPr lang="en-US" sz="1000" dirty="0"/>
+          </a:p>
+        </p:txBody>
+      </p:sp>
+      <p:sp>
+        <p:nvSpPr>
+          <p:cNvPr id="6" name="Text 4"/>
+          <p:cNvSpPr/>
+          <p:nvPr/>
+        </p:nvSpPr>
+        <p:spPr>
+          <a:xfrm>
+            <a:off x="822960" y="2468880"/>
+            <a:ext cx="3657600" cy="365760"/>
+          </a:xfrm>
+          <a:prstGeom prst="rect">
+            <a:avLst/>
+          </a:prstGeom>
+          <a:noFill/>
+          <a:ln/>
+        </p:spPr>
+        <p:txBody>
+          <a:bodyPr wrap="square" lIns="0" tIns="0" rIns="0" bIns="0" rtlCol="0" anchor="t"/>
+          <a:lstStyle/>
+          <a:p>
+            <a:pPr indent="0" marL="0">
+              <a:buNone/>
+            </a:pPr>
+            <a:r>
+              <a:rPr lang="en-US" sz="1300" dirty="0">
+                <a:solidFill>
+                  <a:srgbClr val="16181D"/>
+                </a:solidFill>
+                <a:latin typeface="맑은 고딕" pitchFamily="34" charset="0"/>
+                <a:ea typeface="맑은 고딕" pitchFamily="34" charset="-122"/>
+                <a:cs typeface="맑은 고딕" pitchFamily="34" charset="-120"/>
+              </a:rPr>
+              <a:t>https://www.ai4ceo.app/terms</a:t>
+            </a:r>
+            <a:endParaRPr lang="en-US" sz="1300" dirty="0"/>
+          </a:p>
+        </p:txBody>
+      </p:sp>
+      <p:sp>
+        <p:nvSpPr>
+          <p:cNvPr id="7" name="Text 5"/>
+          <p:cNvSpPr/>
+          <p:nvPr/>
+        </p:nvSpPr>
+        <p:spPr>
+          <a:xfrm>
+            <a:off x="822960" y="3017520"/>
+            <a:ext cx="3657600" cy="2926080"/>
+          </a:xfrm>
+          <a:prstGeom prst="rect">
+            <a:avLst/>
+          </a:prstGeom>
+          <a:noFill/>
+          <a:ln/>
+        </p:spPr>
+        <p:txBody>
+          <a:bodyPr wrap="square" lIns="0" tIns="0" rIns="0" bIns="0" rtlCol="0" anchor="t"/>
+          <a:lstStyle/>
+          <a:p>
+            <a:pPr marL="342900" indent="-342900">
+              <a:lnSpc>
+                <a:spcPct val="125000"/>
+              </a:lnSpc>
+              <a:spcAft>
+                <a:spcPts val="800"/>
+              </a:spcAft>
+              <a:buSzPct val="100000"/>
+              <a:buChar char="•"/>
+            </a:pPr>
+            <a:r>
+              <a:rPr lang="en-US" sz="1300" dirty="0">
+                <a:solidFill>
+                  <a:srgbClr val="5B6472"/>
+                </a:solidFill>
+                <a:latin typeface="맑은 고딕" pitchFamily="34" charset="0"/>
+                <a:ea typeface="맑은 고딕" pitchFamily="34" charset="-122"/>
+                <a:cs typeface="맑은 고딕" pitchFamily="34" charset="-120"/>
+              </a:rPr>
+              <a:t>모든 공개 페이지 하단에서 [결제 및 환불 정책]으로 접속할 수 있는 상시 고정 페이지입니다.</a:t>
+            </a:r>
+            <a:endParaRPr lang="en-US" sz="1300" dirty="0"/>
+          </a:p>
+          <a:p>
+            <a:pPr marL="342900" indent="-342900">
+              <a:lnSpc>
+                <a:spcPct val="125000"/>
+              </a:lnSpc>
+              <a:spcAft>
+                <a:spcPts val="800"/>
+              </a:spcAft>
+              <a:buSzPct val="100000"/>
+              <a:buChar char="•"/>
+            </a:pPr>
+            <a:r>
+              <a:rPr lang="en-US" sz="1300" dirty="0">
+                <a:solidFill>
+                  <a:srgbClr val="5B6472"/>
+                </a:solidFill>
+                <a:latin typeface="맑은 고딕" pitchFamily="34" charset="0"/>
+                <a:ea typeface="맑은 고딕" pitchFamily="34" charset="-122"/>
+                <a:cs typeface="맑은 고딕" pitchFamily="34" charset="-120"/>
+              </a:rPr>
+              <a:t>판매자 정보, 판매 상품별 서비스 제공기간, 결제수단, 환불 규정과 절차를 한 화면에 안내합니다.</a:t>
+            </a:r>
+            <a:endParaRPr lang="en-US" sz="1300" dirty="0"/>
+          </a:p>
+          <a:p>
+            <a:pPr marL="342900" indent="-342900">
+              <a:lnSpc>
+                <a:spcPct val="125000"/>
+              </a:lnSpc>
+              <a:spcAft>
+                <a:spcPts val="800"/>
+              </a:spcAft>
+              <a:buSzPct val="100000"/>
+              <a:buChar char="•"/>
+            </a:pPr>
+            <a:r>
+              <a:rPr lang="en-US" sz="1300" dirty="0">
+                <a:solidFill>
+                  <a:srgbClr val="5B6472"/>
+                </a:solidFill>
+                <a:latin typeface="맑은 고딕" pitchFamily="34" charset="0"/>
+                <a:ea typeface="맑은 고딕" pitchFamily="34" charset="-122"/>
+                <a:cs typeface="맑은 고딕" pitchFamily="34" charset="-120"/>
+              </a:rPr>
+              <a:t>수강료는 개강 전 전액 환불, 개강 후에는 진행 회차를 제외한 잔여 회차 금액을 환불합니다.</a:t>
+            </a:r>
+            <a:endParaRPr lang="en-US" sz="1300" dirty="0"/>
+          </a:p>
+          <a:p>
+            <a:pPr marL="342900" indent="-342900">
+              <a:lnSpc>
+                <a:spcPct val="125000"/>
+              </a:lnSpc>
+              <a:spcAft>
+                <a:spcPts val="800"/>
+              </a:spcAft>
+              <a:buSzPct val="100000"/>
+              <a:buChar char="•"/>
+            </a:pPr>
+            <a:r>
+              <a:rPr lang="en-US" sz="1300" dirty="0">
+                <a:solidFill>
+                  <a:srgbClr val="5B6472"/>
+                </a:solidFill>
+                <a:latin typeface="맑은 고딕" pitchFamily="34" charset="0"/>
+                <a:ea typeface="맑은 고딕" pitchFamily="34" charset="-122"/>
+                <a:cs typeface="맑은 고딕" pitchFamily="34" charset="-120"/>
+              </a:rPr>
+              <a:t>동문 멤버십은 이용 시작 전 전액 환불, 이용 시작 후에는 잔여기간을 일할 계산해 환불합니다.</a:t>
+            </a:r>
+            <a:endParaRPr lang="en-US" sz="1300" dirty="0"/>
+          </a:p>
+        </p:txBody>
+      </p:sp>
+      <p:sp>
+        <p:nvSpPr>
+          <p:cNvPr id="8" name="Shape 6"/>
+          <p:cNvSpPr/>
+          <p:nvPr/>
+        </p:nvSpPr>
+        <p:spPr>
+          <a:xfrm>
+            <a:off x="4800600" y="685800"/>
+            <a:ext cx="6675120" cy="5394960"/>
+          </a:xfrm>
+          <a:prstGeom prst="roundRect">
+            <a:avLst>
+              <a:gd name="adj" fmla="val 1356"/>
+            </a:avLst>
+          </a:prstGeom>
+          <a:solidFill>
+            <a:srgbClr val="F6F8FC"/>
+          </a:solidFill>
+          <a:ln w="12700">
+            <a:solidFill>
+              <a:srgbClr val="E3E7EF"/>
+            </a:solidFill>
+            <a:prstDash val="solid"/>
+          </a:ln>
+        </p:spPr>
+      </p:sp>
+      <p:pic>
+        <p:nvPicPr>
+          <p:cNvPr id="9" name="Picture 8" descr="step6-terms.png"/>
+          <p:cNvPicPr>
+            <a:picLocks noChangeAspect="1"/>
+          </p:cNvPicPr>
+          <p:nvPr/>
+        </p:nvPicPr>
+        <p:blipFill>
+          <a:blip r:embed="rId2"/>
+          <a:stretch>
+            <a:fillRect/>
+          </a:stretch>
+        </p:blipFill>
+        <p:spPr>
+          <a:xfrm>
+            <a:off x="5749622" y="868680"/>
+            <a:ext cx="4777076" cy="5029200"/>
+          </a:xfrm>
+          <a:prstGeom prst="rect">
+            <a:avLst/>
+          </a:prstGeom>
+        </p:spPr>
+      </p:pic>
+    </p:spTree>
+  </p:cSld>
+  <p:clrMapOvr>
+    <a:masterClrMapping/>
+  </p:clrMapOvr>
+</p:sld>
+</file>
+
+<file path=ppt/slides/slide9.xml><?xml version="1.0" encoding="utf-8"?>
 <p:sld xmlns:a="http://schemas.openxmlformats.org/drawingml/2006/main" xmlns:r="http://schemas.openxmlformats.org/officeDocument/2006/relationships" xmlns:p="http://schemas.openxmlformats.org/presentationml/2006/main">
   <p:cSld name="Slide 8">
     <p:bg>

</xml_diff>